<commit_message>
Ajout slide Tests & validation dans la presentation
</commit_message>
<xml_diff>
--- a/docs/Duodingo_Presentation.pptx
+++ b/docs/Duodingo_Presentation.pptx
@@ -18,9 +18,10 @@
     <p:sldId id="266" r:id="rId12"/>
     <p:sldId id="267" r:id="rId13"/>
     <p:sldId id="268" r:id="rId14"/>
+    <p:sldId id="269" r:id="rId15"/>
   </p:sldIdLst>
   <p:notesMasterIdLst>
-    <p:notesMasterId r:id="rId15"/>
+    <p:notesMasterId r:id="rId16"/>
   </p:notesMasterIdLst>
   <p:sldSz cx="12191695" cy="6858000"/>
   <p:notesSz cx="6858000" cy="12191695"/>
@@ -890,6 +891,94 @@
             <a:fld id="{F7021451-1387-4CA6-816F-3879F97B5CBC}" type="slidenum">
               <a:rPr lang="en-US"/>
               <a:t>13</a:t>
+            </a:fld>
+            <a:endParaRPr lang="en-US"/>
+          </a:p>
+        </p:txBody>
+      </p:sp>
+    </p:spTree>
+    <p:extLst>
+      <p:ext uri="{BB962C8B-B14F-4D97-AF65-F5344CB8AC3E}">
+        <p14:creationId xmlns:p14="http://schemas.microsoft.com/office/powerpoint/2010/main" val="1024086991"/>
+      </p:ext>
+    </p:extLst>
+  </p:cSld>
+  <p:clrMapOvr>
+    <a:masterClrMapping/>
+  </p:clrMapOvr>
+</p:notes>
+</file>
+
+<file path=ppt/notesSlides/notesSlide14.xml><?xml version="1.0" encoding="utf-8"?>
+<p:notes xmlns:a="http://schemas.openxmlformats.org/drawingml/2006/main" xmlns:r="http://schemas.openxmlformats.org/officeDocument/2006/relationships" xmlns:p="http://schemas.openxmlformats.org/presentationml/2006/main">
+  <p:cSld>
+    <p:spTree>
+      <p:nvGrpSpPr>
+        <p:cNvPr id="1" name=""/>
+        <p:cNvGrpSpPr/>
+        <p:nvPr/>
+      </p:nvGrpSpPr>
+      <p:grpSpPr>
+        <a:xfrm>
+          <a:off x="0" y="0"/>
+          <a:ext cx="0" cy="0"/>
+          <a:chOff x="0" y="0"/>
+          <a:chExt cx="0" cy="0"/>
+        </a:xfrm>
+      </p:grpSpPr>
+      <p:sp>
+        <p:nvSpPr>
+          <p:cNvPr id="2" name="Slide Image Placeholder 1"/>
+          <p:cNvSpPr>
+            <a:spLocks noGrp="1" noRot="1" noChangeAspect="1"/>
+          </p:cNvSpPr>
+          <p:nvPr>
+            <p:ph type="sldImg"/>
+          </p:nvPr>
+        </p:nvSpPr>
+        <p:spPr/>
+      </p:sp>
+      <p:sp>
+        <p:nvSpPr>
+          <p:cNvPr id="3" name="Notes Placeholder 2"/>
+          <p:cNvSpPr>
+            <a:spLocks noGrp="1"/>
+          </p:cNvSpPr>
+          <p:nvPr>
+            <p:ph type="body" idx="1"/>
+          </p:nvPr>
+        </p:nvSpPr>
+        <p:spPr/>
+        <p:txBody>
+          <a:bodyPr/>
+          <a:lstStyle/>
+          <a:p>
+            <a:r>
+              <a:rPr lang="en-US" dirty="0"/>
+              <a:t/>
+            </a:r>
+            <a:endParaRPr lang="en-US" dirty="0"/>
+          </a:p>
+        </p:txBody>
+      </p:sp>
+      <p:sp>
+        <p:nvSpPr>
+          <p:cNvPr id="4" name="Slide Number Placeholder 3"/>
+          <p:cNvSpPr>
+            <a:spLocks noGrp="1"/>
+          </p:cNvSpPr>
+          <p:nvPr>
+            <p:ph type="sldNum" sz="quarter" idx="10"/>
+          </p:nvPr>
+        </p:nvSpPr>
+        <p:spPr/>
+        <p:txBody>
+          <a:bodyPr/>
+          <a:lstStyle/>
+          <a:p>
+            <a:fld id="{F7021451-1387-4CA6-816F-3879F97B5CBC}" type="slidenum">
+              <a:rPr lang="en-US"/>
+              <a:t>14</a:t>
             </a:fld>
             <a:endParaRPr lang="en-US"/>
           </a:p>
@@ -3012,6 +3101,1670 @@
                 <a:ea typeface="Trebuchet MS" pitchFamily="34" charset="-122"/>
                 <a:cs typeface="Trebuchet MS" pitchFamily="34" charset="-120"/>
               </a:rPr>
+              <a:t>RECETTE FONCTIONNELLE</a:t>
+            </a:r>
+            <a:endParaRPr lang="en-US" sz="1200" dirty="0"/>
+          </a:p>
+        </p:txBody>
+      </p:sp>
+      <p:sp>
+        <p:nvSpPr>
+          <p:cNvPr id="3" name="Text 1"/>
+          <p:cNvSpPr/>
+          <p:nvPr/>
+        </p:nvSpPr>
+        <p:spPr>
+          <a:xfrm>
+            <a:off x="548640" y="640080"/>
+            <a:ext cx="10972800" cy="731520"/>
+          </a:xfrm>
+          <a:prstGeom prst="rect">
+            <a:avLst/>
+          </a:prstGeom>
+          <a:noFill/>
+          <a:ln/>
+        </p:spPr>
+        <p:txBody>
+          <a:bodyPr wrap="square" rtlCol="0" anchor="ctr"/>
+          <a:lstStyle/>
+          <a:p>
+            <a:pPr indent="0" marL="0">
+              <a:buNone/>
+            </a:pPr>
+            <a:r>
+              <a:rPr lang="en-US" sz="3200" b="1" dirty="0">
+                <a:solidFill>
+                  <a:srgbClr val="131F0E"/>
+                </a:solidFill>
+                <a:latin typeface="Trebuchet MS" pitchFamily="34" charset="0"/>
+                <a:ea typeface="Trebuchet MS" pitchFamily="34" charset="-122"/>
+                <a:cs typeface="Trebuchet MS" pitchFamily="34" charset="-120"/>
+              </a:rPr>
+              <a:t>Tests &amp; validation</a:t>
+            </a:r>
+            <a:endParaRPr lang="en-US" sz="3200" dirty="0"/>
+          </a:p>
+        </p:txBody>
+      </p:sp>
+      <p:sp>
+        <p:nvSpPr>
+          <p:cNvPr id="4" name="Text 2"/>
+          <p:cNvSpPr/>
+          <p:nvPr/>
+        </p:nvSpPr>
+        <p:spPr>
+          <a:xfrm>
+            <a:off x="548640" y="1325880"/>
+            <a:ext cx="11064240" cy="548640"/>
+          </a:xfrm>
+          <a:prstGeom prst="rect">
+            <a:avLst/>
+          </a:prstGeom>
+          <a:noFill/>
+          <a:ln/>
+        </p:spPr>
+        <p:txBody>
+          <a:bodyPr wrap="square" rtlCol="0" anchor="ctr"/>
+          <a:lstStyle/>
+          <a:p>
+            <a:pPr indent="0" marL="0">
+              <a:buNone/>
+            </a:pPr>
+            <a:r>
+              <a:rPr lang="en-US" sz="1500" dirty="0">
+                <a:solidFill>
+                  <a:srgbClr val="4B4B4B"/>
+                </a:solidFill>
+                <a:latin typeface="Calibri" pitchFamily="34" charset="0"/>
+                <a:ea typeface="Calibri" pitchFamily="34" charset="-122"/>
+                <a:cs typeface="Calibri" pitchFamily="34" charset="-120"/>
+              </a:rPr>
+              <a:t>Tests fonctionnels manuels réalisés sur émulateur Android (Pixel 7) connecté au backend Node.js et à MongoDB réels — chaque parcours a été déroulé de bout en bout.</a:t>
+            </a:r>
+            <a:endParaRPr lang="en-US" sz="1500" dirty="0"/>
+          </a:p>
+        </p:txBody>
+      </p:sp>
+      <p:sp>
+        <p:nvSpPr>
+          <p:cNvPr id="5" name="Shape 3"/>
+          <p:cNvSpPr/>
+          <p:nvPr/>
+        </p:nvSpPr>
+        <p:spPr>
+          <a:xfrm>
+            <a:off x="548640" y="2057400"/>
+            <a:ext cx="5394960" cy="658368"/>
+          </a:xfrm>
+          <a:prstGeom prst="roundRect">
+            <a:avLst>
+              <a:gd name="adj" fmla="val 13889"/>
+            </a:avLst>
+          </a:prstGeom>
+          <a:solidFill>
+            <a:srgbClr val="F4F8EE"/>
+          </a:solidFill>
+          <a:ln w="12700">
+            <a:solidFill>
+              <a:srgbClr val="E8EDE0"/>
+            </a:solidFill>
+            <a:prstDash val="solid"/>
+          </a:ln>
+        </p:spPr>
+      </p:sp>
+      <p:sp>
+        <p:nvSpPr>
+          <p:cNvPr id="6" name="Shape 4"/>
+          <p:cNvSpPr/>
+          <p:nvPr/>
+        </p:nvSpPr>
+        <p:spPr>
+          <a:xfrm>
+            <a:off x="749808" y="2203704"/>
+            <a:ext cx="365760" cy="365760"/>
+          </a:xfrm>
+          <a:prstGeom prst="ellipse">
+            <a:avLst/>
+          </a:prstGeom>
+          <a:solidFill>
+            <a:srgbClr val="58CC02"/>
+          </a:solidFill>
+          <a:ln/>
+        </p:spPr>
+      </p:sp>
+      <p:sp>
+        <p:nvSpPr>
+          <p:cNvPr id="7" name="Text 5"/>
+          <p:cNvSpPr/>
+          <p:nvPr/>
+        </p:nvSpPr>
+        <p:spPr>
+          <a:xfrm>
+            <a:off x="749808" y="2176272"/>
+            <a:ext cx="365760" cy="365760"/>
+          </a:xfrm>
+          <a:prstGeom prst="rect">
+            <a:avLst/>
+          </a:prstGeom>
+          <a:noFill/>
+          <a:ln/>
+        </p:spPr>
+        <p:txBody>
+          <a:bodyPr wrap="square" rtlCol="0" anchor="ctr"/>
+          <a:lstStyle/>
+          <a:p>
+            <a:pPr algn="ctr" indent="0" marL="0">
+              <a:buNone/>
+            </a:pPr>
+            <a:r>
+              <a:rPr lang="en-US" sz="1600" b="1" dirty="0">
+                <a:solidFill>
+                  <a:srgbClr val="FFFFFF"/>
+                </a:solidFill>
+                <a:latin typeface="Trebuchet MS" pitchFamily="34" charset="0"/>
+                <a:ea typeface="Trebuchet MS" pitchFamily="34" charset="-122"/>
+                <a:cs typeface="Trebuchet MS" pitchFamily="34" charset="-120"/>
+              </a:rPr>
+              <a:t>✓</a:t>
+            </a:r>
+            <a:endParaRPr lang="en-US" sz="1600" dirty="0"/>
+          </a:p>
+        </p:txBody>
+      </p:sp>
+      <p:sp>
+        <p:nvSpPr>
+          <p:cNvPr id="8" name="Text 6"/>
+          <p:cNvSpPr/>
+          <p:nvPr/>
+        </p:nvSpPr>
+        <p:spPr>
+          <a:xfrm>
+            <a:off x="1280160" y="2057400"/>
+            <a:ext cx="4023360" cy="658368"/>
+          </a:xfrm>
+          <a:prstGeom prst="rect">
+            <a:avLst/>
+          </a:prstGeom>
+          <a:noFill/>
+          <a:ln/>
+        </p:spPr>
+        <p:txBody>
+          <a:bodyPr wrap="square" rtlCol="0" anchor="ctr"/>
+          <a:lstStyle/>
+          <a:p>
+            <a:pPr indent="0" marL="0">
+              <a:buNone/>
+            </a:pPr>
+            <a:r>
+              <a:rPr lang="en-US" sz="1400" dirty="0">
+                <a:solidFill>
+                  <a:srgbClr val="131F0E"/>
+                </a:solidFill>
+                <a:latin typeface="Calibri" pitchFamily="34" charset="0"/>
+                <a:ea typeface="Calibri" pitchFamily="34" charset="-122"/>
+                <a:cs typeface="Calibri" pitchFamily="34" charset="-120"/>
+              </a:rPr>
+              <a:t>Inscription &amp; connexion (JWT)</a:t>
+            </a:r>
+            <a:endParaRPr lang="en-US" sz="1400" dirty="0"/>
+          </a:p>
+        </p:txBody>
+      </p:sp>
+      <p:sp>
+        <p:nvSpPr>
+          <p:cNvPr id="9" name="Text 7"/>
+          <p:cNvSpPr/>
+          <p:nvPr/>
+        </p:nvSpPr>
+        <p:spPr>
+          <a:xfrm>
+            <a:off x="5120640" y="2057400"/>
+            <a:ext cx="685800" cy="658368"/>
+          </a:xfrm>
+          <a:prstGeom prst="rect">
+            <a:avLst/>
+          </a:prstGeom>
+          <a:noFill/>
+          <a:ln/>
+        </p:spPr>
+        <p:txBody>
+          <a:bodyPr wrap="square" rtlCol="0" anchor="ctr"/>
+          <a:lstStyle/>
+          <a:p>
+            <a:pPr algn="ctr" indent="0" marL="0">
+              <a:buNone/>
+            </a:pPr>
+            <a:r>
+              <a:rPr lang="en-US" sz="1300" b="1" dirty="0">
+                <a:solidFill>
+                  <a:srgbClr val="3C7A00"/>
+                </a:solidFill>
+                <a:latin typeface="Trebuchet MS" pitchFamily="34" charset="0"/>
+                <a:ea typeface="Trebuchet MS" pitchFamily="34" charset="-122"/>
+                <a:cs typeface="Trebuchet MS" pitchFamily="34" charset="-120"/>
+              </a:rPr>
+              <a:t>OK</a:t>
+            </a:r>
+            <a:endParaRPr lang="en-US" sz="1300" dirty="0"/>
+          </a:p>
+        </p:txBody>
+      </p:sp>
+      <p:sp>
+        <p:nvSpPr>
+          <p:cNvPr id="10" name="Shape 8"/>
+          <p:cNvSpPr/>
+          <p:nvPr/>
+        </p:nvSpPr>
+        <p:spPr>
+          <a:xfrm>
+            <a:off x="6217920" y="2057400"/>
+            <a:ext cx="5394960" cy="658368"/>
+          </a:xfrm>
+          <a:prstGeom prst="roundRect">
+            <a:avLst>
+              <a:gd name="adj" fmla="val 13889"/>
+            </a:avLst>
+          </a:prstGeom>
+          <a:solidFill>
+            <a:srgbClr val="F4F8EE"/>
+          </a:solidFill>
+          <a:ln w="12700">
+            <a:solidFill>
+              <a:srgbClr val="E8EDE0"/>
+            </a:solidFill>
+            <a:prstDash val="solid"/>
+          </a:ln>
+        </p:spPr>
+      </p:sp>
+      <p:sp>
+        <p:nvSpPr>
+          <p:cNvPr id="11" name="Shape 9"/>
+          <p:cNvSpPr/>
+          <p:nvPr/>
+        </p:nvSpPr>
+        <p:spPr>
+          <a:xfrm>
+            <a:off x="6419088" y="2203704"/>
+            <a:ext cx="365760" cy="365760"/>
+          </a:xfrm>
+          <a:prstGeom prst="ellipse">
+            <a:avLst/>
+          </a:prstGeom>
+          <a:solidFill>
+            <a:srgbClr val="58CC02"/>
+          </a:solidFill>
+          <a:ln/>
+        </p:spPr>
+      </p:sp>
+      <p:sp>
+        <p:nvSpPr>
+          <p:cNvPr id="12" name="Text 10"/>
+          <p:cNvSpPr/>
+          <p:nvPr/>
+        </p:nvSpPr>
+        <p:spPr>
+          <a:xfrm>
+            <a:off x="6419088" y="2176272"/>
+            <a:ext cx="365760" cy="365760"/>
+          </a:xfrm>
+          <a:prstGeom prst="rect">
+            <a:avLst/>
+          </a:prstGeom>
+          <a:noFill/>
+          <a:ln/>
+        </p:spPr>
+        <p:txBody>
+          <a:bodyPr wrap="square" rtlCol="0" anchor="ctr"/>
+          <a:lstStyle/>
+          <a:p>
+            <a:pPr algn="ctr" indent="0" marL="0">
+              <a:buNone/>
+            </a:pPr>
+            <a:r>
+              <a:rPr lang="en-US" sz="1600" b="1" dirty="0">
+                <a:solidFill>
+                  <a:srgbClr val="FFFFFF"/>
+                </a:solidFill>
+                <a:latin typeface="Trebuchet MS" pitchFamily="34" charset="0"/>
+                <a:ea typeface="Trebuchet MS" pitchFamily="34" charset="-122"/>
+                <a:cs typeface="Trebuchet MS" pitchFamily="34" charset="-120"/>
+              </a:rPr>
+              <a:t>✓</a:t>
+            </a:r>
+            <a:endParaRPr lang="en-US" sz="1600" dirty="0"/>
+          </a:p>
+        </p:txBody>
+      </p:sp>
+      <p:sp>
+        <p:nvSpPr>
+          <p:cNvPr id="13" name="Text 11"/>
+          <p:cNvSpPr/>
+          <p:nvPr/>
+        </p:nvSpPr>
+        <p:spPr>
+          <a:xfrm>
+            <a:off x="6949440" y="2057400"/>
+            <a:ext cx="4023360" cy="658368"/>
+          </a:xfrm>
+          <a:prstGeom prst="rect">
+            <a:avLst/>
+          </a:prstGeom>
+          <a:noFill/>
+          <a:ln/>
+        </p:spPr>
+        <p:txBody>
+          <a:bodyPr wrap="square" rtlCol="0" anchor="ctr"/>
+          <a:lstStyle/>
+          <a:p>
+            <a:pPr indent="0" marL="0">
+              <a:buNone/>
+            </a:pPr>
+            <a:r>
+              <a:rPr lang="en-US" sz="1400" dirty="0">
+                <a:solidFill>
+                  <a:srgbClr val="131F0E"/>
+                </a:solidFill>
+                <a:latin typeface="Calibri" pitchFamily="34" charset="0"/>
+                <a:ea typeface="Calibri" pitchFamily="34" charset="-122"/>
+                <a:cs typeface="Calibri" pitchFamily="34" charset="-120"/>
+              </a:rPr>
+              <a:t>Chargement des langages &amp; parcours</a:t>
+            </a:r>
+            <a:endParaRPr lang="en-US" sz="1400" dirty="0"/>
+          </a:p>
+        </p:txBody>
+      </p:sp>
+      <p:sp>
+        <p:nvSpPr>
+          <p:cNvPr id="14" name="Text 12"/>
+          <p:cNvSpPr/>
+          <p:nvPr/>
+        </p:nvSpPr>
+        <p:spPr>
+          <a:xfrm>
+            <a:off x="10789920" y="2057400"/>
+            <a:ext cx="685800" cy="658368"/>
+          </a:xfrm>
+          <a:prstGeom prst="rect">
+            <a:avLst/>
+          </a:prstGeom>
+          <a:noFill/>
+          <a:ln/>
+        </p:spPr>
+        <p:txBody>
+          <a:bodyPr wrap="square" rtlCol="0" anchor="ctr"/>
+          <a:lstStyle/>
+          <a:p>
+            <a:pPr algn="ctr" indent="0" marL="0">
+              <a:buNone/>
+            </a:pPr>
+            <a:r>
+              <a:rPr lang="en-US" sz="1300" b="1" dirty="0">
+                <a:solidFill>
+                  <a:srgbClr val="3C7A00"/>
+                </a:solidFill>
+                <a:latin typeface="Trebuchet MS" pitchFamily="34" charset="0"/>
+                <a:ea typeface="Trebuchet MS" pitchFamily="34" charset="-122"/>
+                <a:cs typeface="Trebuchet MS" pitchFamily="34" charset="-120"/>
+              </a:rPr>
+              <a:t>OK</a:t>
+            </a:r>
+            <a:endParaRPr lang="en-US" sz="1300" dirty="0"/>
+          </a:p>
+        </p:txBody>
+      </p:sp>
+      <p:sp>
+        <p:nvSpPr>
+          <p:cNvPr id="15" name="Shape 13"/>
+          <p:cNvSpPr/>
+          <p:nvPr/>
+        </p:nvSpPr>
+        <p:spPr>
+          <a:xfrm>
+            <a:off x="548640" y="2843784"/>
+            <a:ext cx="5394960" cy="658368"/>
+          </a:xfrm>
+          <a:prstGeom prst="roundRect">
+            <a:avLst>
+              <a:gd name="adj" fmla="val 13889"/>
+            </a:avLst>
+          </a:prstGeom>
+          <a:solidFill>
+            <a:srgbClr val="F4F8EE"/>
+          </a:solidFill>
+          <a:ln w="12700">
+            <a:solidFill>
+              <a:srgbClr val="E8EDE0"/>
+            </a:solidFill>
+            <a:prstDash val="solid"/>
+          </a:ln>
+        </p:spPr>
+      </p:sp>
+      <p:sp>
+        <p:nvSpPr>
+          <p:cNvPr id="16" name="Shape 14"/>
+          <p:cNvSpPr/>
+          <p:nvPr/>
+        </p:nvSpPr>
+        <p:spPr>
+          <a:xfrm>
+            <a:off x="749808" y="2990088"/>
+            <a:ext cx="365760" cy="365760"/>
+          </a:xfrm>
+          <a:prstGeom prst="ellipse">
+            <a:avLst/>
+          </a:prstGeom>
+          <a:solidFill>
+            <a:srgbClr val="58CC02"/>
+          </a:solidFill>
+          <a:ln/>
+        </p:spPr>
+      </p:sp>
+      <p:sp>
+        <p:nvSpPr>
+          <p:cNvPr id="17" name="Text 15"/>
+          <p:cNvSpPr/>
+          <p:nvPr/>
+        </p:nvSpPr>
+        <p:spPr>
+          <a:xfrm>
+            <a:off x="749808" y="2962656"/>
+            <a:ext cx="365760" cy="365760"/>
+          </a:xfrm>
+          <a:prstGeom prst="rect">
+            <a:avLst/>
+          </a:prstGeom>
+          <a:noFill/>
+          <a:ln/>
+        </p:spPr>
+        <p:txBody>
+          <a:bodyPr wrap="square" rtlCol="0" anchor="ctr"/>
+          <a:lstStyle/>
+          <a:p>
+            <a:pPr algn="ctr" indent="0" marL="0">
+              <a:buNone/>
+            </a:pPr>
+            <a:r>
+              <a:rPr lang="en-US" sz="1600" b="1" dirty="0">
+                <a:solidFill>
+                  <a:srgbClr val="FFFFFF"/>
+                </a:solidFill>
+                <a:latin typeface="Trebuchet MS" pitchFamily="34" charset="0"/>
+                <a:ea typeface="Trebuchet MS" pitchFamily="34" charset="-122"/>
+                <a:cs typeface="Trebuchet MS" pitchFamily="34" charset="-120"/>
+              </a:rPr>
+              <a:t>✓</a:t>
+            </a:r>
+            <a:endParaRPr lang="en-US" sz="1600" dirty="0"/>
+          </a:p>
+        </p:txBody>
+      </p:sp>
+      <p:sp>
+        <p:nvSpPr>
+          <p:cNvPr id="18" name="Text 16"/>
+          <p:cNvSpPr/>
+          <p:nvPr/>
+        </p:nvSpPr>
+        <p:spPr>
+          <a:xfrm>
+            <a:off x="1280160" y="2843784"/>
+            <a:ext cx="4023360" cy="658368"/>
+          </a:xfrm>
+          <a:prstGeom prst="rect">
+            <a:avLst/>
+          </a:prstGeom>
+          <a:noFill/>
+          <a:ln/>
+        </p:spPr>
+        <p:txBody>
+          <a:bodyPr wrap="square" rtlCol="0" anchor="ctr"/>
+          <a:lstStyle/>
+          <a:p>
+            <a:pPr indent="0" marL="0">
+              <a:buNone/>
+            </a:pPr>
+            <a:r>
+              <a:rPr lang="en-US" sz="1400" dirty="0">
+                <a:solidFill>
+                  <a:srgbClr val="131F0E"/>
+                </a:solidFill>
+                <a:latin typeface="Calibri" pitchFamily="34" charset="0"/>
+                <a:ea typeface="Calibri" pitchFamily="34" charset="-122"/>
+                <a:cs typeface="Calibri" pitchFamily="34" charset="-120"/>
+              </a:rPr>
+              <a:t>QCM — bonne et mauvaise réponse</a:t>
+            </a:r>
+            <a:endParaRPr lang="en-US" sz="1400" dirty="0"/>
+          </a:p>
+        </p:txBody>
+      </p:sp>
+      <p:sp>
+        <p:nvSpPr>
+          <p:cNvPr id="19" name="Text 17"/>
+          <p:cNvSpPr/>
+          <p:nvPr/>
+        </p:nvSpPr>
+        <p:spPr>
+          <a:xfrm>
+            <a:off x="5120640" y="2843784"/>
+            <a:ext cx="685800" cy="658368"/>
+          </a:xfrm>
+          <a:prstGeom prst="rect">
+            <a:avLst/>
+          </a:prstGeom>
+          <a:noFill/>
+          <a:ln/>
+        </p:spPr>
+        <p:txBody>
+          <a:bodyPr wrap="square" rtlCol="0" anchor="ctr"/>
+          <a:lstStyle/>
+          <a:p>
+            <a:pPr algn="ctr" indent="0" marL="0">
+              <a:buNone/>
+            </a:pPr>
+            <a:r>
+              <a:rPr lang="en-US" sz="1300" b="1" dirty="0">
+                <a:solidFill>
+                  <a:srgbClr val="3C7A00"/>
+                </a:solidFill>
+                <a:latin typeface="Trebuchet MS" pitchFamily="34" charset="0"/>
+                <a:ea typeface="Trebuchet MS" pitchFamily="34" charset="-122"/>
+                <a:cs typeface="Trebuchet MS" pitchFamily="34" charset="-120"/>
+              </a:rPr>
+              <a:t>OK</a:t>
+            </a:r>
+            <a:endParaRPr lang="en-US" sz="1300" dirty="0"/>
+          </a:p>
+        </p:txBody>
+      </p:sp>
+      <p:sp>
+        <p:nvSpPr>
+          <p:cNvPr id="20" name="Shape 18"/>
+          <p:cNvSpPr/>
+          <p:nvPr/>
+        </p:nvSpPr>
+        <p:spPr>
+          <a:xfrm>
+            <a:off x="6217920" y="2843784"/>
+            <a:ext cx="5394960" cy="658368"/>
+          </a:xfrm>
+          <a:prstGeom prst="roundRect">
+            <a:avLst>
+              <a:gd name="adj" fmla="val 13889"/>
+            </a:avLst>
+          </a:prstGeom>
+          <a:solidFill>
+            <a:srgbClr val="F4F8EE"/>
+          </a:solidFill>
+          <a:ln w="12700">
+            <a:solidFill>
+              <a:srgbClr val="E8EDE0"/>
+            </a:solidFill>
+            <a:prstDash val="solid"/>
+          </a:ln>
+        </p:spPr>
+      </p:sp>
+      <p:sp>
+        <p:nvSpPr>
+          <p:cNvPr id="21" name="Shape 19"/>
+          <p:cNvSpPr/>
+          <p:nvPr/>
+        </p:nvSpPr>
+        <p:spPr>
+          <a:xfrm>
+            <a:off x="6419088" y="2990088"/>
+            <a:ext cx="365760" cy="365760"/>
+          </a:xfrm>
+          <a:prstGeom prst="ellipse">
+            <a:avLst/>
+          </a:prstGeom>
+          <a:solidFill>
+            <a:srgbClr val="58CC02"/>
+          </a:solidFill>
+          <a:ln/>
+        </p:spPr>
+      </p:sp>
+      <p:sp>
+        <p:nvSpPr>
+          <p:cNvPr id="22" name="Text 20"/>
+          <p:cNvSpPr/>
+          <p:nvPr/>
+        </p:nvSpPr>
+        <p:spPr>
+          <a:xfrm>
+            <a:off x="6419088" y="2962656"/>
+            <a:ext cx="365760" cy="365760"/>
+          </a:xfrm>
+          <a:prstGeom prst="rect">
+            <a:avLst/>
+          </a:prstGeom>
+          <a:noFill/>
+          <a:ln/>
+        </p:spPr>
+        <p:txBody>
+          <a:bodyPr wrap="square" rtlCol="0" anchor="ctr"/>
+          <a:lstStyle/>
+          <a:p>
+            <a:pPr algn="ctr" indent="0" marL="0">
+              <a:buNone/>
+            </a:pPr>
+            <a:r>
+              <a:rPr lang="en-US" sz="1600" b="1" dirty="0">
+                <a:solidFill>
+                  <a:srgbClr val="FFFFFF"/>
+                </a:solidFill>
+                <a:latin typeface="Trebuchet MS" pitchFamily="34" charset="0"/>
+                <a:ea typeface="Trebuchet MS" pitchFamily="34" charset="-122"/>
+                <a:cs typeface="Trebuchet MS" pitchFamily="34" charset="-120"/>
+              </a:rPr>
+              <a:t>✓</a:t>
+            </a:r>
+            <a:endParaRPr lang="en-US" sz="1600" dirty="0"/>
+          </a:p>
+        </p:txBody>
+      </p:sp>
+      <p:sp>
+        <p:nvSpPr>
+          <p:cNvPr id="23" name="Text 21"/>
+          <p:cNvSpPr/>
+          <p:nvPr/>
+        </p:nvSpPr>
+        <p:spPr>
+          <a:xfrm>
+            <a:off x="6949440" y="2843784"/>
+            <a:ext cx="4023360" cy="658368"/>
+          </a:xfrm>
+          <a:prstGeom prst="rect">
+            <a:avLst/>
+          </a:prstGeom>
+          <a:noFill/>
+          <a:ln/>
+        </p:spPr>
+        <p:txBody>
+          <a:bodyPr wrap="square" rtlCol="0" anchor="ctr"/>
+          <a:lstStyle/>
+          <a:p>
+            <a:pPr indent="0" marL="0">
+              <a:buNone/>
+            </a:pPr>
+            <a:r>
+              <a:rPr lang="en-US" sz="1400" dirty="0">
+                <a:solidFill>
+                  <a:srgbClr val="131F0E"/>
+                </a:solidFill>
+                <a:latin typeface="Calibri" pitchFamily="34" charset="0"/>
+                <a:ea typeface="Calibri" pitchFamily="34" charset="-122"/>
+                <a:cs typeface="Calibri" pitchFamily="34" charset="-120"/>
+              </a:rPr>
+              <a:t>Vrai / Faux</a:t>
+            </a:r>
+            <a:endParaRPr lang="en-US" sz="1400" dirty="0"/>
+          </a:p>
+        </p:txBody>
+      </p:sp>
+      <p:sp>
+        <p:nvSpPr>
+          <p:cNvPr id="24" name="Text 22"/>
+          <p:cNvSpPr/>
+          <p:nvPr/>
+        </p:nvSpPr>
+        <p:spPr>
+          <a:xfrm>
+            <a:off x="10789920" y="2843784"/>
+            <a:ext cx="685800" cy="658368"/>
+          </a:xfrm>
+          <a:prstGeom prst="rect">
+            <a:avLst/>
+          </a:prstGeom>
+          <a:noFill/>
+          <a:ln/>
+        </p:spPr>
+        <p:txBody>
+          <a:bodyPr wrap="square" rtlCol="0" anchor="ctr"/>
+          <a:lstStyle/>
+          <a:p>
+            <a:pPr algn="ctr" indent="0" marL="0">
+              <a:buNone/>
+            </a:pPr>
+            <a:r>
+              <a:rPr lang="en-US" sz="1300" b="1" dirty="0">
+                <a:solidFill>
+                  <a:srgbClr val="3C7A00"/>
+                </a:solidFill>
+                <a:latin typeface="Trebuchet MS" pitchFamily="34" charset="0"/>
+                <a:ea typeface="Trebuchet MS" pitchFamily="34" charset="-122"/>
+                <a:cs typeface="Trebuchet MS" pitchFamily="34" charset="-120"/>
+              </a:rPr>
+              <a:t>OK</a:t>
+            </a:r>
+            <a:endParaRPr lang="en-US" sz="1300" dirty="0"/>
+          </a:p>
+        </p:txBody>
+      </p:sp>
+      <p:sp>
+        <p:nvSpPr>
+          <p:cNvPr id="25" name="Shape 23"/>
+          <p:cNvSpPr/>
+          <p:nvPr/>
+        </p:nvSpPr>
+        <p:spPr>
+          <a:xfrm>
+            <a:off x="548640" y="3630168"/>
+            <a:ext cx="5394960" cy="658368"/>
+          </a:xfrm>
+          <a:prstGeom prst="roundRect">
+            <a:avLst>
+              <a:gd name="adj" fmla="val 13889"/>
+            </a:avLst>
+          </a:prstGeom>
+          <a:solidFill>
+            <a:srgbClr val="F4F8EE"/>
+          </a:solidFill>
+          <a:ln w="12700">
+            <a:solidFill>
+              <a:srgbClr val="E8EDE0"/>
+            </a:solidFill>
+            <a:prstDash val="solid"/>
+          </a:ln>
+        </p:spPr>
+      </p:sp>
+      <p:sp>
+        <p:nvSpPr>
+          <p:cNvPr id="26" name="Shape 24"/>
+          <p:cNvSpPr/>
+          <p:nvPr/>
+        </p:nvSpPr>
+        <p:spPr>
+          <a:xfrm>
+            <a:off x="749808" y="3776472"/>
+            <a:ext cx="365760" cy="365760"/>
+          </a:xfrm>
+          <a:prstGeom prst="ellipse">
+            <a:avLst/>
+          </a:prstGeom>
+          <a:solidFill>
+            <a:srgbClr val="58CC02"/>
+          </a:solidFill>
+          <a:ln/>
+        </p:spPr>
+      </p:sp>
+      <p:sp>
+        <p:nvSpPr>
+          <p:cNvPr id="27" name="Text 25"/>
+          <p:cNvSpPr/>
+          <p:nvPr/>
+        </p:nvSpPr>
+        <p:spPr>
+          <a:xfrm>
+            <a:off x="749808" y="3749040"/>
+            <a:ext cx="365760" cy="365760"/>
+          </a:xfrm>
+          <a:prstGeom prst="rect">
+            <a:avLst/>
+          </a:prstGeom>
+          <a:noFill/>
+          <a:ln/>
+        </p:spPr>
+        <p:txBody>
+          <a:bodyPr wrap="square" rtlCol="0" anchor="ctr"/>
+          <a:lstStyle/>
+          <a:p>
+            <a:pPr algn="ctr" indent="0" marL="0">
+              <a:buNone/>
+            </a:pPr>
+            <a:r>
+              <a:rPr lang="en-US" sz="1600" b="1" dirty="0">
+                <a:solidFill>
+                  <a:srgbClr val="FFFFFF"/>
+                </a:solidFill>
+                <a:latin typeface="Trebuchet MS" pitchFamily="34" charset="0"/>
+                <a:ea typeface="Trebuchet MS" pitchFamily="34" charset="-122"/>
+                <a:cs typeface="Trebuchet MS" pitchFamily="34" charset="-120"/>
+              </a:rPr>
+              <a:t>✓</a:t>
+            </a:r>
+            <a:endParaRPr lang="en-US" sz="1600" dirty="0"/>
+          </a:p>
+        </p:txBody>
+      </p:sp>
+      <p:sp>
+        <p:nvSpPr>
+          <p:cNvPr id="28" name="Text 26"/>
+          <p:cNvSpPr/>
+          <p:nvPr/>
+        </p:nvSpPr>
+        <p:spPr>
+          <a:xfrm>
+            <a:off x="1280160" y="3630168"/>
+            <a:ext cx="4023360" cy="658368"/>
+          </a:xfrm>
+          <a:prstGeom prst="rect">
+            <a:avLst/>
+          </a:prstGeom>
+          <a:noFill/>
+          <a:ln/>
+        </p:spPr>
+        <p:txBody>
+          <a:bodyPr wrap="square" rtlCol="0" anchor="ctr"/>
+          <a:lstStyle/>
+          <a:p>
+            <a:pPr indent="0" marL="0">
+              <a:buNone/>
+            </a:pPr>
+            <a:r>
+              <a:rPr lang="en-US" sz="1400" dirty="0">
+                <a:solidFill>
+                  <a:srgbClr val="131F0E"/>
+                </a:solidFill>
+                <a:latin typeface="Calibri" pitchFamily="34" charset="0"/>
+                <a:ea typeface="Calibri" pitchFamily="34" charset="-122"/>
+                <a:cs typeface="Calibri" pitchFamily="34" charset="-120"/>
+              </a:rPr>
+              <a:t>Compléter le code (code à trous)</a:t>
+            </a:r>
+            <a:endParaRPr lang="en-US" sz="1400" dirty="0"/>
+          </a:p>
+        </p:txBody>
+      </p:sp>
+      <p:sp>
+        <p:nvSpPr>
+          <p:cNvPr id="29" name="Text 27"/>
+          <p:cNvSpPr/>
+          <p:nvPr/>
+        </p:nvSpPr>
+        <p:spPr>
+          <a:xfrm>
+            <a:off x="5120640" y="3630168"/>
+            <a:ext cx="685800" cy="658368"/>
+          </a:xfrm>
+          <a:prstGeom prst="rect">
+            <a:avLst/>
+          </a:prstGeom>
+          <a:noFill/>
+          <a:ln/>
+        </p:spPr>
+        <p:txBody>
+          <a:bodyPr wrap="square" rtlCol="0" anchor="ctr"/>
+          <a:lstStyle/>
+          <a:p>
+            <a:pPr algn="ctr" indent="0" marL="0">
+              <a:buNone/>
+            </a:pPr>
+            <a:r>
+              <a:rPr lang="en-US" sz="1300" b="1" dirty="0">
+                <a:solidFill>
+                  <a:srgbClr val="3C7A00"/>
+                </a:solidFill>
+                <a:latin typeface="Trebuchet MS" pitchFamily="34" charset="0"/>
+                <a:ea typeface="Trebuchet MS" pitchFamily="34" charset="-122"/>
+                <a:cs typeface="Trebuchet MS" pitchFamily="34" charset="-120"/>
+              </a:rPr>
+              <a:t>OK</a:t>
+            </a:r>
+            <a:endParaRPr lang="en-US" sz="1300" dirty="0"/>
+          </a:p>
+        </p:txBody>
+      </p:sp>
+      <p:sp>
+        <p:nvSpPr>
+          <p:cNvPr id="30" name="Shape 28"/>
+          <p:cNvSpPr/>
+          <p:nvPr/>
+        </p:nvSpPr>
+        <p:spPr>
+          <a:xfrm>
+            <a:off x="6217920" y="3630168"/>
+            <a:ext cx="5394960" cy="658368"/>
+          </a:xfrm>
+          <a:prstGeom prst="roundRect">
+            <a:avLst>
+              <a:gd name="adj" fmla="val 13889"/>
+            </a:avLst>
+          </a:prstGeom>
+          <a:solidFill>
+            <a:srgbClr val="F4F8EE"/>
+          </a:solidFill>
+          <a:ln w="12700">
+            <a:solidFill>
+              <a:srgbClr val="E8EDE0"/>
+            </a:solidFill>
+            <a:prstDash val="solid"/>
+          </a:ln>
+        </p:spPr>
+      </p:sp>
+      <p:sp>
+        <p:nvSpPr>
+          <p:cNvPr id="31" name="Shape 29"/>
+          <p:cNvSpPr/>
+          <p:nvPr/>
+        </p:nvSpPr>
+        <p:spPr>
+          <a:xfrm>
+            <a:off x="6419088" y="3776472"/>
+            <a:ext cx="365760" cy="365760"/>
+          </a:xfrm>
+          <a:prstGeom prst="ellipse">
+            <a:avLst/>
+          </a:prstGeom>
+          <a:solidFill>
+            <a:srgbClr val="58CC02"/>
+          </a:solidFill>
+          <a:ln/>
+        </p:spPr>
+      </p:sp>
+      <p:sp>
+        <p:nvSpPr>
+          <p:cNvPr id="32" name="Text 30"/>
+          <p:cNvSpPr/>
+          <p:nvPr/>
+        </p:nvSpPr>
+        <p:spPr>
+          <a:xfrm>
+            <a:off x="6419088" y="3749040"/>
+            <a:ext cx="365760" cy="365760"/>
+          </a:xfrm>
+          <a:prstGeom prst="rect">
+            <a:avLst/>
+          </a:prstGeom>
+          <a:noFill/>
+          <a:ln/>
+        </p:spPr>
+        <p:txBody>
+          <a:bodyPr wrap="square" rtlCol="0" anchor="ctr"/>
+          <a:lstStyle/>
+          <a:p>
+            <a:pPr algn="ctr" indent="0" marL="0">
+              <a:buNone/>
+            </a:pPr>
+            <a:r>
+              <a:rPr lang="en-US" sz="1600" b="1" dirty="0">
+                <a:solidFill>
+                  <a:srgbClr val="FFFFFF"/>
+                </a:solidFill>
+                <a:latin typeface="Trebuchet MS" pitchFamily="34" charset="0"/>
+                <a:ea typeface="Trebuchet MS" pitchFamily="34" charset="-122"/>
+                <a:cs typeface="Trebuchet MS" pitchFamily="34" charset="-120"/>
+              </a:rPr>
+              <a:t>✓</a:t>
+            </a:r>
+            <a:endParaRPr lang="en-US" sz="1600" dirty="0"/>
+          </a:p>
+        </p:txBody>
+      </p:sp>
+      <p:sp>
+        <p:nvSpPr>
+          <p:cNvPr id="33" name="Text 31"/>
+          <p:cNvSpPr/>
+          <p:nvPr/>
+        </p:nvSpPr>
+        <p:spPr>
+          <a:xfrm>
+            <a:off x="6949440" y="3630168"/>
+            <a:ext cx="4023360" cy="658368"/>
+          </a:xfrm>
+          <a:prstGeom prst="rect">
+            <a:avLst/>
+          </a:prstGeom>
+          <a:noFill/>
+          <a:ln/>
+        </p:spPr>
+        <p:txBody>
+          <a:bodyPr wrap="square" rtlCol="0" anchor="ctr"/>
+          <a:lstStyle/>
+          <a:p>
+            <a:pPr indent="0" marL="0">
+              <a:buNone/>
+            </a:pPr>
+            <a:r>
+              <a:rPr lang="en-US" sz="1400" dirty="0">
+                <a:solidFill>
+                  <a:srgbClr val="131F0E"/>
+                </a:solidFill>
+                <a:latin typeface="Calibri" pitchFamily="34" charset="0"/>
+                <a:ea typeface="Calibri" pitchFamily="34" charset="-122"/>
+                <a:cs typeface="Calibri" pitchFamily="34" charset="-120"/>
+              </a:rPr>
+              <a:t>Remettre le code dans l’ordre</a:t>
+            </a:r>
+            <a:endParaRPr lang="en-US" sz="1400" dirty="0"/>
+          </a:p>
+        </p:txBody>
+      </p:sp>
+      <p:sp>
+        <p:nvSpPr>
+          <p:cNvPr id="34" name="Text 32"/>
+          <p:cNvSpPr/>
+          <p:nvPr/>
+        </p:nvSpPr>
+        <p:spPr>
+          <a:xfrm>
+            <a:off x="10789920" y="3630168"/>
+            <a:ext cx="685800" cy="658368"/>
+          </a:xfrm>
+          <a:prstGeom prst="rect">
+            <a:avLst/>
+          </a:prstGeom>
+          <a:noFill/>
+          <a:ln/>
+        </p:spPr>
+        <p:txBody>
+          <a:bodyPr wrap="square" rtlCol="0" anchor="ctr"/>
+          <a:lstStyle/>
+          <a:p>
+            <a:pPr algn="ctr" indent="0" marL="0">
+              <a:buNone/>
+            </a:pPr>
+            <a:r>
+              <a:rPr lang="en-US" sz="1300" b="1" dirty="0">
+                <a:solidFill>
+                  <a:srgbClr val="3C7A00"/>
+                </a:solidFill>
+                <a:latin typeface="Trebuchet MS" pitchFamily="34" charset="0"/>
+                <a:ea typeface="Trebuchet MS" pitchFamily="34" charset="-122"/>
+                <a:cs typeface="Trebuchet MS" pitchFamily="34" charset="-120"/>
+              </a:rPr>
+              <a:t>OK</a:t>
+            </a:r>
+            <a:endParaRPr lang="en-US" sz="1300" dirty="0"/>
+          </a:p>
+        </p:txBody>
+      </p:sp>
+      <p:sp>
+        <p:nvSpPr>
+          <p:cNvPr id="35" name="Shape 33"/>
+          <p:cNvSpPr/>
+          <p:nvPr/>
+        </p:nvSpPr>
+        <p:spPr>
+          <a:xfrm>
+            <a:off x="548640" y="4416552"/>
+            <a:ext cx="5394960" cy="658368"/>
+          </a:xfrm>
+          <a:prstGeom prst="roundRect">
+            <a:avLst>
+              <a:gd name="adj" fmla="val 13889"/>
+            </a:avLst>
+          </a:prstGeom>
+          <a:solidFill>
+            <a:srgbClr val="F4F8EE"/>
+          </a:solidFill>
+          <a:ln w="12700">
+            <a:solidFill>
+              <a:srgbClr val="E8EDE0"/>
+            </a:solidFill>
+            <a:prstDash val="solid"/>
+          </a:ln>
+        </p:spPr>
+      </p:sp>
+      <p:sp>
+        <p:nvSpPr>
+          <p:cNvPr id="36" name="Shape 34"/>
+          <p:cNvSpPr/>
+          <p:nvPr/>
+        </p:nvSpPr>
+        <p:spPr>
+          <a:xfrm>
+            <a:off x="749808" y="4562856"/>
+            <a:ext cx="365760" cy="365760"/>
+          </a:xfrm>
+          <a:prstGeom prst="ellipse">
+            <a:avLst/>
+          </a:prstGeom>
+          <a:solidFill>
+            <a:srgbClr val="58CC02"/>
+          </a:solidFill>
+          <a:ln/>
+        </p:spPr>
+      </p:sp>
+      <p:sp>
+        <p:nvSpPr>
+          <p:cNvPr id="37" name="Text 35"/>
+          <p:cNvSpPr/>
+          <p:nvPr/>
+        </p:nvSpPr>
+        <p:spPr>
+          <a:xfrm>
+            <a:off x="749808" y="4535424"/>
+            <a:ext cx="365760" cy="365760"/>
+          </a:xfrm>
+          <a:prstGeom prst="rect">
+            <a:avLst/>
+          </a:prstGeom>
+          <a:noFill/>
+          <a:ln/>
+        </p:spPr>
+        <p:txBody>
+          <a:bodyPr wrap="square" rtlCol="0" anchor="ctr"/>
+          <a:lstStyle/>
+          <a:p>
+            <a:pPr algn="ctr" indent="0" marL="0">
+              <a:buNone/>
+            </a:pPr>
+            <a:r>
+              <a:rPr lang="en-US" sz="1600" b="1" dirty="0">
+                <a:solidFill>
+                  <a:srgbClr val="FFFFFF"/>
+                </a:solidFill>
+                <a:latin typeface="Trebuchet MS" pitchFamily="34" charset="0"/>
+                <a:ea typeface="Trebuchet MS" pitchFamily="34" charset="-122"/>
+                <a:cs typeface="Trebuchet MS" pitchFamily="34" charset="-120"/>
+              </a:rPr>
+              <a:t>✓</a:t>
+            </a:r>
+            <a:endParaRPr lang="en-US" sz="1600" dirty="0"/>
+          </a:p>
+        </p:txBody>
+      </p:sp>
+      <p:sp>
+        <p:nvSpPr>
+          <p:cNvPr id="38" name="Text 36"/>
+          <p:cNvSpPr/>
+          <p:nvPr/>
+        </p:nvSpPr>
+        <p:spPr>
+          <a:xfrm>
+            <a:off x="1280160" y="4416552"/>
+            <a:ext cx="4023360" cy="658368"/>
+          </a:xfrm>
+          <a:prstGeom prst="rect">
+            <a:avLst/>
+          </a:prstGeom>
+          <a:noFill/>
+          <a:ln/>
+        </p:spPr>
+        <p:txBody>
+          <a:bodyPr wrap="square" rtlCol="0" anchor="ctr"/>
+          <a:lstStyle/>
+          <a:p>
+            <a:pPr indent="0" marL="0">
+              <a:buNone/>
+            </a:pPr>
+            <a:r>
+              <a:rPr lang="en-US" sz="1400" dirty="0">
+                <a:solidFill>
+                  <a:srgbClr val="131F0E"/>
+                </a:solidFill>
+                <a:latin typeface="Calibri" pitchFamily="34" charset="0"/>
+                <a:ea typeface="Calibri" pitchFamily="34" charset="-122"/>
+                <a:cs typeface="Calibri" pitchFamily="34" charset="-120"/>
+              </a:rPr>
+              <a:t>Perte d’un cœur sur erreur</a:t>
+            </a:r>
+            <a:endParaRPr lang="en-US" sz="1400" dirty="0"/>
+          </a:p>
+        </p:txBody>
+      </p:sp>
+      <p:sp>
+        <p:nvSpPr>
+          <p:cNvPr id="39" name="Text 37"/>
+          <p:cNvSpPr/>
+          <p:nvPr/>
+        </p:nvSpPr>
+        <p:spPr>
+          <a:xfrm>
+            <a:off x="5120640" y="4416552"/>
+            <a:ext cx="685800" cy="658368"/>
+          </a:xfrm>
+          <a:prstGeom prst="rect">
+            <a:avLst/>
+          </a:prstGeom>
+          <a:noFill/>
+          <a:ln/>
+        </p:spPr>
+        <p:txBody>
+          <a:bodyPr wrap="square" rtlCol="0" anchor="ctr"/>
+          <a:lstStyle/>
+          <a:p>
+            <a:pPr algn="ctr" indent="0" marL="0">
+              <a:buNone/>
+            </a:pPr>
+            <a:r>
+              <a:rPr lang="en-US" sz="1300" b="1" dirty="0">
+                <a:solidFill>
+                  <a:srgbClr val="3C7A00"/>
+                </a:solidFill>
+                <a:latin typeface="Trebuchet MS" pitchFamily="34" charset="0"/>
+                <a:ea typeface="Trebuchet MS" pitchFamily="34" charset="-122"/>
+                <a:cs typeface="Trebuchet MS" pitchFamily="34" charset="-120"/>
+              </a:rPr>
+              <a:t>OK</a:t>
+            </a:r>
+            <a:endParaRPr lang="en-US" sz="1300" dirty="0"/>
+          </a:p>
+        </p:txBody>
+      </p:sp>
+      <p:sp>
+        <p:nvSpPr>
+          <p:cNvPr id="40" name="Shape 38"/>
+          <p:cNvSpPr/>
+          <p:nvPr/>
+        </p:nvSpPr>
+        <p:spPr>
+          <a:xfrm>
+            <a:off x="6217920" y="4416552"/>
+            <a:ext cx="5394960" cy="658368"/>
+          </a:xfrm>
+          <a:prstGeom prst="roundRect">
+            <a:avLst>
+              <a:gd name="adj" fmla="val 13889"/>
+            </a:avLst>
+          </a:prstGeom>
+          <a:solidFill>
+            <a:srgbClr val="F4F8EE"/>
+          </a:solidFill>
+          <a:ln w="12700">
+            <a:solidFill>
+              <a:srgbClr val="E8EDE0"/>
+            </a:solidFill>
+            <a:prstDash val="solid"/>
+          </a:ln>
+        </p:spPr>
+      </p:sp>
+      <p:sp>
+        <p:nvSpPr>
+          <p:cNvPr id="41" name="Shape 39"/>
+          <p:cNvSpPr/>
+          <p:nvPr/>
+        </p:nvSpPr>
+        <p:spPr>
+          <a:xfrm>
+            <a:off x="6419088" y="4562856"/>
+            <a:ext cx="365760" cy="365760"/>
+          </a:xfrm>
+          <a:prstGeom prst="ellipse">
+            <a:avLst/>
+          </a:prstGeom>
+          <a:solidFill>
+            <a:srgbClr val="58CC02"/>
+          </a:solidFill>
+          <a:ln/>
+        </p:spPr>
+      </p:sp>
+      <p:sp>
+        <p:nvSpPr>
+          <p:cNvPr id="42" name="Text 40"/>
+          <p:cNvSpPr/>
+          <p:nvPr/>
+        </p:nvSpPr>
+        <p:spPr>
+          <a:xfrm>
+            <a:off x="6419088" y="4535424"/>
+            <a:ext cx="365760" cy="365760"/>
+          </a:xfrm>
+          <a:prstGeom prst="rect">
+            <a:avLst/>
+          </a:prstGeom>
+          <a:noFill/>
+          <a:ln/>
+        </p:spPr>
+        <p:txBody>
+          <a:bodyPr wrap="square" rtlCol="0" anchor="ctr"/>
+          <a:lstStyle/>
+          <a:p>
+            <a:pPr algn="ctr" indent="0" marL="0">
+              <a:buNone/>
+            </a:pPr>
+            <a:r>
+              <a:rPr lang="en-US" sz="1600" b="1" dirty="0">
+                <a:solidFill>
+                  <a:srgbClr val="FFFFFF"/>
+                </a:solidFill>
+                <a:latin typeface="Trebuchet MS" pitchFamily="34" charset="0"/>
+                <a:ea typeface="Trebuchet MS" pitchFamily="34" charset="-122"/>
+                <a:cs typeface="Trebuchet MS" pitchFamily="34" charset="-120"/>
+              </a:rPr>
+              <a:t>✓</a:t>
+            </a:r>
+            <a:endParaRPr lang="en-US" sz="1600" dirty="0"/>
+          </a:p>
+        </p:txBody>
+      </p:sp>
+      <p:sp>
+        <p:nvSpPr>
+          <p:cNvPr id="43" name="Text 41"/>
+          <p:cNvSpPr/>
+          <p:nvPr/>
+        </p:nvSpPr>
+        <p:spPr>
+          <a:xfrm>
+            <a:off x="6949440" y="4416552"/>
+            <a:ext cx="4023360" cy="658368"/>
+          </a:xfrm>
+          <a:prstGeom prst="rect">
+            <a:avLst/>
+          </a:prstGeom>
+          <a:noFill/>
+          <a:ln/>
+        </p:spPr>
+        <p:txBody>
+          <a:bodyPr wrap="square" rtlCol="0" anchor="ctr"/>
+          <a:lstStyle/>
+          <a:p>
+            <a:pPr indent="0" marL="0">
+              <a:buNone/>
+            </a:pPr>
+            <a:r>
+              <a:rPr lang="en-US" sz="1400" dirty="0">
+                <a:solidFill>
+                  <a:srgbClr val="131F0E"/>
+                </a:solidFill>
+                <a:latin typeface="Calibri" pitchFamily="34" charset="0"/>
+                <a:ea typeface="Calibri" pitchFamily="34" charset="-122"/>
+                <a:cs typeface="Calibri" pitchFamily="34" charset="-120"/>
+              </a:rPr>
+              <a:t>Fin de leçon : gain d’XP &amp; succès</a:t>
+            </a:r>
+            <a:endParaRPr lang="en-US" sz="1400" dirty="0"/>
+          </a:p>
+        </p:txBody>
+      </p:sp>
+      <p:sp>
+        <p:nvSpPr>
+          <p:cNvPr id="44" name="Text 42"/>
+          <p:cNvSpPr/>
+          <p:nvPr/>
+        </p:nvSpPr>
+        <p:spPr>
+          <a:xfrm>
+            <a:off x="10789920" y="4416552"/>
+            <a:ext cx="685800" cy="658368"/>
+          </a:xfrm>
+          <a:prstGeom prst="rect">
+            <a:avLst/>
+          </a:prstGeom>
+          <a:noFill/>
+          <a:ln/>
+        </p:spPr>
+        <p:txBody>
+          <a:bodyPr wrap="square" rtlCol="0" anchor="ctr"/>
+          <a:lstStyle/>
+          <a:p>
+            <a:pPr algn="ctr" indent="0" marL="0">
+              <a:buNone/>
+            </a:pPr>
+            <a:r>
+              <a:rPr lang="en-US" sz="1300" b="1" dirty="0">
+                <a:solidFill>
+                  <a:srgbClr val="3C7A00"/>
+                </a:solidFill>
+                <a:latin typeface="Trebuchet MS" pitchFamily="34" charset="0"/>
+                <a:ea typeface="Trebuchet MS" pitchFamily="34" charset="-122"/>
+                <a:cs typeface="Trebuchet MS" pitchFamily="34" charset="-120"/>
+              </a:rPr>
+              <a:t>OK</a:t>
+            </a:r>
+            <a:endParaRPr lang="en-US" sz="1300" dirty="0"/>
+          </a:p>
+        </p:txBody>
+      </p:sp>
+      <p:sp>
+        <p:nvSpPr>
+          <p:cNvPr id="45" name="Shape 43"/>
+          <p:cNvSpPr/>
+          <p:nvPr/>
+        </p:nvSpPr>
+        <p:spPr>
+          <a:xfrm>
+            <a:off x="548640" y="5202936"/>
+            <a:ext cx="5394960" cy="658368"/>
+          </a:xfrm>
+          <a:prstGeom prst="roundRect">
+            <a:avLst>
+              <a:gd name="adj" fmla="val 13889"/>
+            </a:avLst>
+          </a:prstGeom>
+          <a:solidFill>
+            <a:srgbClr val="F4F8EE"/>
+          </a:solidFill>
+          <a:ln w="12700">
+            <a:solidFill>
+              <a:srgbClr val="E8EDE0"/>
+            </a:solidFill>
+            <a:prstDash val="solid"/>
+          </a:ln>
+        </p:spPr>
+      </p:sp>
+      <p:sp>
+        <p:nvSpPr>
+          <p:cNvPr id="46" name="Shape 44"/>
+          <p:cNvSpPr/>
+          <p:nvPr/>
+        </p:nvSpPr>
+        <p:spPr>
+          <a:xfrm>
+            <a:off x="749808" y="5349240"/>
+            <a:ext cx="365760" cy="365760"/>
+          </a:xfrm>
+          <a:prstGeom prst="ellipse">
+            <a:avLst/>
+          </a:prstGeom>
+          <a:solidFill>
+            <a:srgbClr val="58CC02"/>
+          </a:solidFill>
+          <a:ln/>
+        </p:spPr>
+      </p:sp>
+      <p:sp>
+        <p:nvSpPr>
+          <p:cNvPr id="47" name="Text 45"/>
+          <p:cNvSpPr/>
+          <p:nvPr/>
+        </p:nvSpPr>
+        <p:spPr>
+          <a:xfrm>
+            <a:off x="749808" y="5321808"/>
+            <a:ext cx="365760" cy="365760"/>
+          </a:xfrm>
+          <a:prstGeom prst="rect">
+            <a:avLst/>
+          </a:prstGeom>
+          <a:noFill/>
+          <a:ln/>
+        </p:spPr>
+        <p:txBody>
+          <a:bodyPr wrap="square" rtlCol="0" anchor="ctr"/>
+          <a:lstStyle/>
+          <a:p>
+            <a:pPr algn="ctr" indent="0" marL="0">
+              <a:buNone/>
+            </a:pPr>
+            <a:r>
+              <a:rPr lang="en-US" sz="1600" b="1" dirty="0">
+                <a:solidFill>
+                  <a:srgbClr val="FFFFFF"/>
+                </a:solidFill>
+                <a:latin typeface="Trebuchet MS" pitchFamily="34" charset="0"/>
+                <a:ea typeface="Trebuchet MS" pitchFamily="34" charset="-122"/>
+                <a:cs typeface="Trebuchet MS" pitchFamily="34" charset="-120"/>
+              </a:rPr>
+              <a:t>✓</a:t>
+            </a:r>
+            <a:endParaRPr lang="en-US" sz="1600" dirty="0"/>
+          </a:p>
+        </p:txBody>
+      </p:sp>
+      <p:sp>
+        <p:nvSpPr>
+          <p:cNvPr id="48" name="Text 46"/>
+          <p:cNvSpPr/>
+          <p:nvPr/>
+        </p:nvSpPr>
+        <p:spPr>
+          <a:xfrm>
+            <a:off x="1280160" y="5202936"/>
+            <a:ext cx="4023360" cy="658368"/>
+          </a:xfrm>
+          <a:prstGeom prst="rect">
+            <a:avLst/>
+          </a:prstGeom>
+          <a:noFill/>
+          <a:ln/>
+        </p:spPr>
+        <p:txBody>
+          <a:bodyPr wrap="square" rtlCol="0" anchor="ctr"/>
+          <a:lstStyle/>
+          <a:p>
+            <a:pPr indent="0" marL="0">
+              <a:buNone/>
+            </a:pPr>
+            <a:r>
+              <a:rPr lang="en-US" sz="1400" dirty="0">
+                <a:solidFill>
+                  <a:srgbClr val="131F0E"/>
+                </a:solidFill>
+                <a:latin typeface="Calibri" pitchFamily="34" charset="0"/>
+                <a:ea typeface="Calibri" pitchFamily="34" charset="-122"/>
+                <a:cs typeface="Calibri" pitchFamily="34" charset="-120"/>
+              </a:rPr>
+              <a:t>Défi du jour, classement &amp; profil</a:t>
+            </a:r>
+            <a:endParaRPr lang="en-US" sz="1400" dirty="0"/>
+          </a:p>
+        </p:txBody>
+      </p:sp>
+      <p:sp>
+        <p:nvSpPr>
+          <p:cNvPr id="49" name="Text 47"/>
+          <p:cNvSpPr/>
+          <p:nvPr/>
+        </p:nvSpPr>
+        <p:spPr>
+          <a:xfrm>
+            <a:off x="5120640" y="5202936"/>
+            <a:ext cx="685800" cy="658368"/>
+          </a:xfrm>
+          <a:prstGeom prst="rect">
+            <a:avLst/>
+          </a:prstGeom>
+          <a:noFill/>
+          <a:ln/>
+        </p:spPr>
+        <p:txBody>
+          <a:bodyPr wrap="square" rtlCol="0" anchor="ctr"/>
+          <a:lstStyle/>
+          <a:p>
+            <a:pPr algn="ctr" indent="0" marL="0">
+              <a:buNone/>
+            </a:pPr>
+            <a:r>
+              <a:rPr lang="en-US" sz="1300" b="1" dirty="0">
+                <a:solidFill>
+                  <a:srgbClr val="3C7A00"/>
+                </a:solidFill>
+                <a:latin typeface="Trebuchet MS" pitchFamily="34" charset="0"/>
+                <a:ea typeface="Trebuchet MS" pitchFamily="34" charset="-122"/>
+                <a:cs typeface="Trebuchet MS" pitchFamily="34" charset="-120"/>
+              </a:rPr>
+              <a:t>OK</a:t>
+            </a:r>
+            <a:endParaRPr lang="en-US" sz="1300" dirty="0"/>
+          </a:p>
+        </p:txBody>
+      </p:sp>
+      <p:sp>
+        <p:nvSpPr>
+          <p:cNvPr id="50" name="Text 48"/>
+          <p:cNvSpPr/>
+          <p:nvPr/>
+        </p:nvSpPr>
+        <p:spPr>
+          <a:xfrm>
+            <a:off x="548640" y="6263640"/>
+            <a:ext cx="11064240" cy="365760"/>
+          </a:xfrm>
+          <a:prstGeom prst="rect">
+            <a:avLst/>
+          </a:prstGeom>
+          <a:noFill/>
+          <a:ln/>
+        </p:spPr>
+        <p:txBody>
+          <a:bodyPr wrap="square" rtlCol="0" anchor="ctr"/>
+          <a:lstStyle/>
+          <a:p>
+            <a:pPr indent="0" marL="0">
+              <a:buNone/>
+            </a:pPr>
+            <a:r>
+              <a:rPr lang="en-US" sz="1300" i="1" dirty="0">
+                <a:solidFill>
+                  <a:srgbClr val="4B4B4B"/>
+                </a:solidFill>
+                <a:latin typeface="Calibri" pitchFamily="34" charset="0"/>
+                <a:ea typeface="Calibri" pitchFamily="34" charset="-122"/>
+                <a:cs typeface="Calibri" pitchFamily="34" charset="-120"/>
+              </a:rPr>
+              <a:t>Résultat — parcours validé de bout en bout · 17 captures réelles · compte de test à 85 XP avec succès débloqués.</a:t>
+            </a:r>
+            <a:endParaRPr lang="en-US" sz="1300" dirty="0"/>
+          </a:p>
+        </p:txBody>
+      </p:sp>
+    </p:spTree>
+  </p:cSld>
+  <p:clrMapOvr>
+    <a:masterClrMapping/>
+  </p:clrMapOvr>
+</p:sld>
+</file>
+
+<file path=ppt/slides/slide13.xml><?xml version="1.0" encoding="utf-8"?>
+<p:sld xmlns:a="http://schemas.openxmlformats.org/drawingml/2006/main" xmlns:r="http://schemas.openxmlformats.org/officeDocument/2006/relationships" xmlns:p="http://schemas.openxmlformats.org/presentationml/2006/main">
+  <p:cSld name="Slide 13">
+    <p:bg>
+      <p:bgPr>
+        <a:solidFill>
+          <a:srgbClr val="FFFFFF"/>
+        </a:solidFill>
+      </p:bgPr>
+    </p:bg>
+    <p:spTree>
+      <p:nvGrpSpPr>
+        <p:cNvPr id="1" name=""/>
+        <p:cNvGrpSpPr/>
+        <p:nvPr/>
+      </p:nvGrpSpPr>
+      <p:grpSpPr>
+        <a:xfrm>
+          <a:off x="0" y="0"/>
+          <a:ext cx="0" cy="0"/>
+          <a:chOff x="0" y="0"/>
+          <a:chExt cx="0" cy="0"/>
+        </a:xfrm>
+      </p:grpSpPr>
+      <p:sp>
+        <p:nvSpPr>
+          <p:cNvPr id="2" name="Text 0"/>
+          <p:cNvSpPr/>
+          <p:nvPr/>
+        </p:nvSpPr>
+        <p:spPr>
+          <a:xfrm>
+            <a:off x="548640" y="411480"/>
+            <a:ext cx="8229600" cy="274320"/>
+          </a:xfrm>
+          <a:prstGeom prst="rect">
+            <a:avLst/>
+          </a:prstGeom>
+          <a:noFill/>
+          <a:ln/>
+        </p:spPr>
+        <p:txBody>
+          <a:bodyPr wrap="square" rtlCol="0" anchor="ctr"/>
+          <a:lstStyle/>
+          <a:p>
+            <a:pPr indent="0" marL="0">
+              <a:buNone/>
+            </a:pPr>
+            <a:r>
+              <a:rPr lang="en-US" sz="1200" b="1" spc="200" kern="0" dirty="0">
+                <a:solidFill>
+                  <a:srgbClr val="58CC02"/>
+                </a:solidFill>
+                <a:latin typeface="Trebuchet MS" pitchFamily="34" charset="0"/>
+                <a:ea typeface="Trebuchet MS" pitchFamily="34" charset="-122"/>
+                <a:cs typeface="Trebuchet MS" pitchFamily="34" charset="-120"/>
+              </a:rPr>
               <a:t>RETOUR TECHNIQUE</a:t>
             </a:r>
             <a:endParaRPr lang="en-US" sz="1200" dirty="0"/>
@@ -3657,9 +5410,9 @@
 </p:sld>
 </file>
 
-<file path=ppt/slides/slide13.xml><?xml version="1.0" encoding="utf-8"?>
+<file path=ppt/slides/slide14.xml><?xml version="1.0" encoding="utf-8"?>
 <p:sld xmlns:a="http://schemas.openxmlformats.org/drawingml/2006/main" xmlns:r="http://schemas.openxmlformats.org/officeDocument/2006/relationships" xmlns:p="http://schemas.openxmlformats.org/presentationml/2006/main">
-  <p:cSld name="Slide 13">
+  <p:cSld name="Slide 14">
     <p:bg>
       <p:bgPr>
         <a:solidFill>

</xml_diff>